<commit_message>
Fix Slide 9 presentation layout bug in src/build_presentation.py
- Remove p_note from headline text frame in src/build_presentation.py
- Position Clinical Insight paragraph in dedicated textbox cleanly below stat cards at top=4.85in
- Regenerate presentations/project_presentation.pptx
- Verify clean layout with zero text overlap and run full test suite

Co-authored-by: kommoji-Harsha <250546658+kommoji-Harsha@users.noreply.github.com>
</commit_message>
<xml_diff>
--- a/presentations/project_presentation.pptx
+++ b/presentations/project_presentation.pptx
@@ -13359,21 +13359,6 @@
               <a:t>High Accuracy Can Hide a Model That Is Barely Discriminating At All</a:t>
             </a:r>
           </a:p>
-          <a:p>
-            <a:pPr>
-              <a:spcBef>
-                <a:spcPts val="10500"/>
-              </a:spcBef>
-              <a:defRPr sz="1200">
-                <a:solidFill>
-                  <a:srgbClr val="1F2937"/>
-                </a:solidFill>
-              </a:defRPr>
-            </a:pPr>
-            <a:r>
-              <a:t>Clinical Insight: Because 92.7% of patients in the Switzerland cohort had heart disease, a naive model predicting 'disease' almost constantly achieves 91.1% accuracy and 97.4% recall. However, its 11.1% specificity reveals it fails to identify healthy patients. Disaggregating metrics by site was essential to surface this prevalence bias.</a:t>
-            </a:r>
-          </a:p>
         </p:txBody>
       </p:sp>
       <p:sp>
@@ -13736,6 +13721,42 @@
             </a:pPr>
             <a:r>
               <a:t>Specificity (TNR)</a:t>
+            </a:r>
+          </a:p>
+        </p:txBody>
+      </p:sp>
+      <p:sp>
+        <p:nvSpPr>
+          <p:cNvPr id="15" name="TextBox 14"/>
+          <p:cNvSpPr txBox="1"/>
+          <p:nvPr/>
+        </p:nvSpPr>
+        <p:spPr>
+          <a:xfrm>
+            <a:off x="1005840" y="4434840"/>
+            <a:ext cx="10177272" cy="1463040"/>
+          </a:xfrm>
+          <a:prstGeom prst="rect">
+            <a:avLst/>
+          </a:prstGeom>
+          <a:noFill/>
+        </p:spPr>
+        <p:txBody>
+          <a:bodyPr wrap="square">
+            <a:spAutoFit/>
+          </a:bodyPr>
+          <a:lstStyle/>
+          <a:p>
+            <a:pPr>
+              <a:defRPr sz="1200">
+                <a:solidFill>
+                  <a:srgbClr val="1F2937"/>
+                </a:solidFill>
+                <a:latin typeface="Calibri"/>
+              </a:defRPr>
+            </a:pPr>
+            <a:r>
+              <a:t>Clinical Insight: Because 92.7% of patients in the Switzerland cohort had heart disease, a naive model predicting 'disease' almost constantly achieves 91.1% accuracy and 97.4% recall. However, its 11.1% specificity reveals it fails to identify healthy patients. Disaggregating metrics by site was essential to surface this prevalence bias.</a:t>
             </a:r>
           </a:p>
         </p:txBody>

</xml_diff>